<commit_message>
Use the new green logo in the demo day deck
The cover and closing slides show the full logo; every content slide's
footer shows the mark. Rebuilt the PPTX, the PDF and the slide previews.
</commit_message>
<xml_diff>
--- a/presentation/StableSave-Demo-Day.pptx
+++ b/presentation/StableSave-Demo-Day.pptx
@@ -118,13 +118,13 @@
   <p:extLst>
     <p:ext uri="{521415D9-36F7-43E2-AB2F-B90AF26B5E84}">
       <p14:sectionLst xmlns:p14="http://schemas.microsoft.com/office/powerpoint/2010/main">
-        <p14:section name="Opening" id="{29714e4c-fbc4-bd61-8bee-08b4e9153f7a}">
+        <p14:section name="Opening" id="{1453872c-6fd8-945c-c1c9-3dcc2cdc4c14}">
           <p14:sldIdLst>
             <p14:sldId id="256"/>
             <p14:sldId id="257"/>
           </p14:sldIdLst>
         </p14:section>
-        <p14:section name="Product" id="{57ad6446-439e-08da-b3d4-33df742f44b7}">
+        <p14:section name="Product" id="{54ef1a65-c51b-428d-7dda-d7ddf3b7cfe8}">
           <p14:sldIdLst>
             <p14:sldId id="258"/>
             <p14:sldId id="259"/>
@@ -132,24 +132,24 @@
             <p14:sldId id="261"/>
           </p14:sldIdLst>
         </p14:section>
-        <p14:section name="Solana vault" id="{ad127431-1cde-e7f2-add4-b340e88364c2}">
+        <p14:section name="Solana vault" id="{526e2912-d717-85f4-07f3-097ecd53b137}">
           <p14:sldIdLst>
             <p14:sldId id="262"/>
             <p14:sldId id="263"/>
           </p14:sldIdLst>
         </p14:section>
-        <p14:section name="Demo" id="{c7628424-0b3d-97b9-86f4-916ab1489fa6}">
+        <p14:section name="Demo" id="{03abe777-2233-3fd1-8de9-28cac553ca9c}">
           <p14:sldIdLst>
             <p14:sldId id="264"/>
           </p14:sldIdLst>
         </p14:section>
-        <p14:section name="Status and roadmap" id="{2510bdf5-88c6-1897-62ce-78d0c84a25aa}">
+        <p14:section name="Status and roadmap" id="{81df5f95-40d1-b7b6-d3a3-0e4a14f5bddb}">
           <p14:sldIdLst>
             <p14:sldId id="265"/>
             <p14:sldId id="266"/>
           </p14:sldIdLst>
         </p14:section>
-        <p14:section name="Close" id="{4ed00531-5e57-44a6-90b4-bc06fcdf26a5}">
+        <p14:section name="Close" id="{570b196b-66eb-3baf-1b53-80315b03eb23}">
           <p14:sldIdLst>
             <p14:sldId id="267"/>
           </p14:sldIdLst>
@@ -2554,7 +2554,7 @@
       </p:grpSpPr>
       <p:pic>
         <p:nvPicPr>
-          <p:cNvPr id="2" name="logo-mark" descr="StableSave logo: three stacked coins">    </p:cNvPr>
+          <p:cNvPr id="2" name="logo" descr="StableSave logo">    </p:cNvPr>
           <p:cNvPicPr>
             <a:picLocks noChangeAspect="1"/>
           </p:cNvPicPr>
@@ -2569,7 +2569,7 @@
         <p:spPr>
           <a:xfrm>
             <a:off x="548640" y="566928"/>
-            <a:ext cx="420624" cy="420624"/>
+            <a:ext cx="3012141" cy="384048"/>
           </a:xfrm>
           <a:prstGeom prst="rect">
             <a:avLst/>
@@ -2578,43 +2578,7 @@
       </p:pic>
       <p:sp>
         <p:nvSpPr>
-          <p:cNvPr id="3" name="wordmark"/>
-          <p:cNvSpPr txBox="1"/>
-          <p:nvPr/>
-        </p:nvSpPr>
-        <p:spPr>
-          <a:xfrm>
-            <a:off x="1097280" y="566928"/>
-            <a:ext cx="3657600" cy="420624"/>
-          </a:xfrm>
-          <a:prstGeom prst="rect">
-            <a:avLst/>
-          </a:prstGeom>
-          <a:noFill/>
-          <a:ln/>
-        </p:spPr>
-        <p:txBody>
-          <a:bodyPr wrap="square" lIns="0" tIns="0" rIns="0" bIns="0" rtlCol="0" anchor="ctr"/>
-          <a:lstStyle/>
-          <a:p>
-            <a:pPr indent="0" marL="0">
-              <a:buNone/>
-            </a:pPr>
-            <a:r>
-              <a:rPr lang="en-US" sz="2400" b="1" dirty="0">
-                <a:solidFill>
-                  <a:schemeClr val="bg1"/>
-                </a:solidFill>
-              </a:rPr>
-              <a:t>StableSave</a:t>
-            </a:r>
-            <a:endParaRPr lang="en-US" sz="2400" dirty="0"/>
-          </a:p>
-        </p:txBody>
-      </p:sp>
-      <p:sp>
-        <p:nvSpPr>
-          <p:cNvPr id="4" name="descriptor"/>
+          <p:cNvPr id="3" name="descriptor"/>
           <p:cNvSpPr txBox="1"/>
           <p:nvPr/>
         </p:nvSpPr>
@@ -2650,7 +2614,7 @@
       </p:sp>
       <p:sp>
         <p:nvSpPr>
-          <p:cNvPr id="5" name="headline"/>
+          <p:cNvPr id="4" name="headline"/>
           <p:cNvSpPr txBox="1"/>
           <p:nvPr/>
         </p:nvSpPr>
@@ -2703,7 +2667,7 @@
       </p:sp>
       <p:sp>
         <p:nvSpPr>
-          <p:cNvPr id="6" name="subhead"/>
+          <p:cNvPr id="5" name="subhead"/>
           <p:cNvSpPr txBox="1"/>
           <p:nvPr/>
         </p:nvSpPr>
@@ -2742,7 +2706,7 @@
       </p:sp>
       <p:sp>
         <p:nvSpPr>
-          <p:cNvPr id="7" name="presenter"/>
+          <p:cNvPr id="6" name="presenter"/>
           <p:cNvSpPr txBox="1"/>
           <p:nvPr/>
         </p:nvSpPr>
@@ -5191,7 +5155,7 @@
         <p:spPr>
           <a:xfrm>
             <a:off x="548640" y="566928"/>
-            <a:ext cx="365760" cy="365760"/>
+            <a:ext cx="2581835" cy="329184"/>
           </a:xfrm>
           <a:prstGeom prst="rect">
             <a:avLst/>
@@ -5201,42 +5165,6 @@
       <p:sp>
         <p:nvSpPr>
           <p:cNvPr id="3" name="Text 0"/>
-          <p:cNvSpPr txBox="1"/>
-          <p:nvPr/>
-        </p:nvSpPr>
-        <p:spPr>
-          <a:xfrm>
-            <a:off x="1051560" y="566928"/>
-            <a:ext cx="3657600" cy="365760"/>
-          </a:xfrm>
-          <a:prstGeom prst="rect">
-            <a:avLst/>
-          </a:prstGeom>
-          <a:noFill/>
-          <a:ln/>
-        </p:spPr>
-        <p:txBody>
-          <a:bodyPr wrap="square" lIns="0" tIns="0" rIns="0" bIns="0" rtlCol="0" anchor="ctr"/>
-          <a:lstStyle/>
-          <a:p>
-            <a:pPr indent="0" marL="0">
-              <a:buNone/>
-            </a:pPr>
-            <a:r>
-              <a:rPr lang="en-US" sz="2000" b="1" dirty="0">
-                <a:solidFill>
-                  <a:schemeClr val="bg1"/>
-                </a:solidFill>
-              </a:rPr>
-              <a:t>StableSave</a:t>
-            </a:r>
-            <a:endParaRPr lang="en-US" sz="2000" dirty="0"/>
-          </a:p>
-        </p:txBody>
-      </p:sp>
-      <p:sp>
-        <p:nvSpPr>
-          <p:cNvPr id="4" name="Text 1"/>
           <p:cNvSpPr txBox="1"/>
           <p:nvPr/>
         </p:nvSpPr>
@@ -5275,7 +5203,7 @@
       </p:sp>
       <p:pic>
         <p:nvPicPr>
-          <p:cNvPr id="5" name="Image 1" descr="Simpler comparison">    </p:cNvPr>
+          <p:cNvPr id="4" name="Image 1" descr="Simpler comparison">    </p:cNvPr>
           <p:cNvPicPr>
             <a:picLocks noChangeAspect="1"/>
           </p:cNvPicPr>
@@ -5299,7 +5227,7 @@
       </p:pic>
       <p:sp>
         <p:nvSpPr>
-          <p:cNvPr id="6" name="Text 2"/>
+          <p:cNvPr id="5" name="Text 1"/>
           <p:cNvSpPr txBox="1"/>
           <p:nvPr/>
         </p:nvSpPr>
@@ -5335,7 +5263,7 @@
       </p:sp>
       <p:sp>
         <p:nvSpPr>
-          <p:cNvPr id="7" name="Text 3"/>
+          <p:cNvPr id="6" name="Text 2"/>
           <p:cNvSpPr txBox="1"/>
           <p:nvPr/>
         </p:nvSpPr>
@@ -5371,7 +5299,7 @@
       </p:sp>
       <p:pic>
         <p:nvPicPr>
-          <p:cNvPr id="8" name="Image 2" descr="Risk grades that show trade-offs">    </p:cNvPr>
+          <p:cNvPr id="7" name="Image 2" descr="Risk grades that show trade-offs">    </p:cNvPr>
           <p:cNvPicPr>
             <a:picLocks noChangeAspect="1"/>
           </p:cNvPicPr>
@@ -5395,7 +5323,7 @@
       </p:pic>
       <p:sp>
         <p:nvSpPr>
-          <p:cNvPr id="9" name="Text 4"/>
+          <p:cNvPr id="8" name="Text 3"/>
           <p:cNvSpPr txBox="1"/>
           <p:nvPr/>
         </p:nvSpPr>
@@ -5431,7 +5359,7 @@
       </p:sp>
       <p:sp>
         <p:nvSpPr>
-          <p:cNvPr id="10" name="Text 5"/>
+          <p:cNvPr id="9" name="Text 4"/>
           <p:cNvSpPr txBox="1"/>
           <p:nvPr/>
         </p:nvSpPr>
@@ -5467,7 +5395,7 @@
       </p:sp>
       <p:pic>
         <p:nvPicPr>
-          <p:cNvPr id="11" name="Image 3" descr="A separate Solana vault prototype">    </p:cNvPr>
+          <p:cNvPr id="10" name="Image 3" descr="A separate Solana vault prototype">    </p:cNvPr>
           <p:cNvPicPr>
             <a:picLocks noChangeAspect="1"/>
           </p:cNvPicPr>
@@ -5491,7 +5419,7 @@
       </p:pic>
       <p:sp>
         <p:nvSpPr>
-          <p:cNvPr id="12" name="Text 6"/>
+          <p:cNvPr id="11" name="Text 5"/>
           <p:cNvSpPr txBox="1"/>
           <p:nvPr/>
         </p:nvSpPr>
@@ -5527,7 +5455,7 @@
       </p:sp>
       <p:sp>
         <p:nvSpPr>
-          <p:cNvPr id="13" name="Text 7"/>
+          <p:cNvPr id="12" name="Text 6"/>
           <p:cNvSpPr txBox="1"/>
           <p:nvPr/>
         </p:nvSpPr>
@@ -5563,7 +5491,7 @@
       </p:sp>
       <p:sp>
         <p:nvSpPr>
-          <p:cNvPr id="14" name="qr-card"/>
+          <p:cNvPr id="13" name="qr-card"/>
           <p:cNvSpPr/>
           <p:nvPr/>
         </p:nvSpPr>
@@ -5592,7 +5520,7 @@
       </p:sp>
       <p:pic>
         <p:nvPicPr>
-          <p:cNvPr id="15" name="Image 4" descr="QR code linking to stablesaver-web.vercel.app">    </p:cNvPr>
+          <p:cNvPr id="14" name="Image 4" descr="QR code linking to stablesaver-web.vercel.app">    </p:cNvPr>
           <p:cNvPicPr>
             <a:picLocks noChangeAspect="1"/>
           </p:cNvPicPr>
@@ -5616,7 +5544,7 @@
       </p:pic>
       <p:sp>
         <p:nvSpPr>
-          <p:cNvPr id="16" name="Text 9"/>
+          <p:cNvPr id="15" name="Text 8"/>
           <p:cNvSpPr txBox="1"/>
           <p:nvPr/>
         </p:nvSpPr>
@@ -5652,7 +5580,7 @@
       </p:sp>
       <p:sp>
         <p:nvSpPr>
-          <p:cNvPr id="17" name="Text 10"/>
+          <p:cNvPr id="16" name="Text 9"/>
           <p:cNvSpPr txBox="1"/>
           <p:nvPr/>
         </p:nvSpPr>
@@ -5688,7 +5616,7 @@
       </p:sp>
       <p:sp>
         <p:nvSpPr>
-          <p:cNvPr id="18" name="Text 11"/>
+          <p:cNvPr id="17" name="Text 10"/>
           <p:cNvSpPr txBox="1"/>
           <p:nvPr/>
         </p:nvSpPr>
@@ -5724,7 +5652,7 @@
       </p:sp>
       <p:sp>
         <p:nvSpPr>
-          <p:cNvPr id="19" name="Text 12"/>
+          <p:cNvPr id="18" name="Text 11"/>
           <p:cNvSpPr txBox="1"/>
           <p:nvPr/>
         </p:nvSpPr>

</xml_diff>

<commit_message>
Bring the demo day deck up to date with the new features
The vault slide shows the practice pools (16 instructions); the demo
runbook covers the idle-money scan, withdraw-today, the Treasury bill
comparison, share cards, the split into pools, rebalancing and the deposit
Blink; the status slide, roadmap and Q&A notes say what's practice and
what's still to come. Rebuilt the PPTX, PDF and previews.
</commit_message>
<xml_diff>
--- a/presentation/StableSave-Demo-Day.pptx
+++ b/presentation/StableSave-Demo-Day.pptx
@@ -118,13 +118,13 @@
   <p:extLst>
     <p:ext uri="{521415D9-36F7-43E2-AB2F-B90AF26B5E84}">
       <p14:sectionLst xmlns:p14="http://schemas.microsoft.com/office/powerpoint/2010/main">
-        <p14:section name="Opening" id="{1453872c-6fd8-945c-c1c9-3dcc2cdc4c14}">
+        <p14:section name="Opening" id="{528b18ac-c856-f207-2a95-44cbf840824a}">
           <p14:sldIdLst>
             <p14:sldId id="256"/>
             <p14:sldId id="257"/>
           </p14:sldIdLst>
         </p14:section>
-        <p14:section name="Product" id="{54ef1a65-c51b-428d-7dda-d7ddf3b7cfe8}">
+        <p14:section name="Product" id="{ec6076d5-5dc5-9447-e621-f5026f036c44}">
           <p14:sldIdLst>
             <p14:sldId id="258"/>
             <p14:sldId id="259"/>
@@ -132,24 +132,24 @@
             <p14:sldId id="261"/>
           </p14:sldIdLst>
         </p14:section>
-        <p14:section name="Solana vault" id="{526e2912-d717-85f4-07f3-097ecd53b137}">
+        <p14:section name="Solana vault" id="{be47d773-9c6f-968a-803f-862ff64aa03f}">
           <p14:sldIdLst>
             <p14:sldId id="262"/>
             <p14:sldId id="263"/>
           </p14:sldIdLst>
         </p14:section>
-        <p14:section name="Demo" id="{03abe777-2233-3fd1-8de9-28cac553ca9c}">
+        <p14:section name="Demo" id="{6c0c7c6e-4d49-a425-0f9f-fa3df9de0a94}">
           <p14:sldIdLst>
             <p14:sldId id="264"/>
           </p14:sldIdLst>
         </p14:section>
-        <p14:section name="Status and roadmap" id="{81df5f95-40d1-b7b6-d3a3-0e4a14f5bddb}">
+        <p14:section name="Status and roadmap" id="{18f59093-7033-2e56-df0c-adfea61742bb}">
           <p14:sldIdLst>
             <p14:sldId id="265"/>
             <p14:sldId id="266"/>
           </p14:sldIdLst>
         </p14:section>
-        <p14:section name="Close" id="{570b196b-66eb-3baf-1b53-80315b03eb23}">
+        <p14:section name="Close" id="{0e4bca8f-5898-fbfd-28d8-dd65cd437be8}">
           <p14:sldIdLst>
             <p14:sldId id="267"/>
           </p14:sldIdLst>
@@ -920,9 +920,9 @@
               <a:t>TIME: about 35 seconds.
 Key message: I know exactly what's real, what's experimental and what's missing. That's a strength, not an apology.
 Talking points:
-- Live today: the comparison, DefiLlama-backed pool data, the grades with their reasons, fee-adjusted estimates, and an optional API (/v1/opportunities, /v1/estimate, /v1/strategies).
-- Devnet prototype: the Anchor vault with deposits, shares, withdrawal limits, the timelock, pause and authority controls.
-- Not yet: the allocator, so the vault earns nothing. Deployed balances must be read on-chain. Today deployed_assets is zero, and if an admin reported it, the share price would be whatever the admin says. That's why it has to be on-chain. And no production security assurances: no audit.
+- Live today: the comparison on DefiLlama data, the grades with their reasons, fee-adjusted estimates, "Can I withdraw today?", the US Treasury bill comparison, the idle-money wallet scan, shareable estimate cards, and an optional API.
+- Devnet prototype: the Anchor vault with deposits, shares, withdrawal limits, the timelock, pause and authority controls; a permissionless rebalance that splits deposits into practice pools by the on-chain strategy; and a deposit Blink.
+- Not yet: CPI into the real protocols, so no market yield through the vault. Every balance the vault counts is already a real token in an account it owns, read on-chain, never reported by an admin. And no production security assurances: no audit.
 - Other limits: one data source, fixed fee estimates, weights that are my judgement and not back-tested, ranking on today's APY rather than the 30-day average, bridging not modelled, and admin and upgrade-key risk.
 Transition: Here's the order I'll fix them in.</a:t>
             </a:r>
@@ -1017,8 +1017,8 @@
 Talking points:
 - Phase 1, safety: an escape hatch so withdrawals reopen if a vault stays paused too long; close_position to refund account rent; fuzz testing the share math and withdrawal limits.
 - Phase 2, recommendations: rank on the 30-day average instead of today's rate; flag options that need funds moved between networks; back-test the grades against past exploits.
-- Phase 3, the vault: one real Kamino lending integration, tested against the real Kamino program on a local validator, with the deployed balance read on-chain.
-- Phase 4: a multisig authority and a delay on strategy changes, then Solana Actions and Blinks, rate and grade alerts, a read-only portfolio view, and more tokens such as USDT and Token-2022.
+- Phase 3, the vault: replace a practice pool with one real Kamino lending integration, tested against the real Kamino program on a local validator. The rebalance and the on-chain accounting stay the same.
+- Phase 4: a multisig authority and a delay on strategy changes, then rate and grade alerts, a read-only portfolio view, and more tokens such as USDT and Token-2022.
 All of this is planned, none of it is built yet. Don't give dates you can't commit to.
 Transition: To wrap up.</a:t>
             </a:r>
@@ -1116,7 +1116,7 @@
 - I'd love feedback on three things: the risk scoring, the vault's security model, and which integration I should build next.
 - Close: StableSave. Know the risk before you chase the yield. Thank you.
 Likely questions and honest answers:
-- Does the vault earn yield? Not yet. Deposits stay in the reserve; the Kamino allocator is the next major build.
+- Does the vault earn yield? Not market yield yet. On devnet it splits deposits into practice pools that pay fixed practice rates from a sponsor pot of test tokens; swapping one for a real Kamino strategy is the next build.
 - Is it audited? No. It's a devnet prototype.
 - Who controls the vault? One authority key today, plus a guardian that can only pause. A multisig and a delay on strategy changes are planned.
 - Why trust the grades? They're transparent: every factor and its reason is shown, and unknowns lower the grade. The weights are my judgement and not back-tested yet.
@@ -1696,17 +1696,17 @@
             <a:r>
               <a:rPr lang="en-US" dirty="0"/>
               <a:t>TIME: about 50 seconds.
-SAY THIS CLEARLY: this is a separate component, and it's a devnet prototype. It does not earn yield and it is not audited.
+SAY THIS CLEARLY: this is a separate component, and it's a devnet prototype. It splits deposits into practice pools, not real protocols, and it is not audited.
 Key message: the rules of the vault are enforced on-chain by the program, not by the website.
 Talking points:
-- The vault is one Anchor program on Solana devnet with 13 instructions.
+- The vault is one Anchor program on Solana devnet with 16 instructions.
 - It uses three kinds of account. These are PDAs: program-derived addresses, which only the program can sign for.
   - Vault: the settings. Who the admins are, the limits, the strategy weights, the share totals. One per token and risk level.
-  - Reserve: holds the deposited tokens. Only the vault can sign a transfer out.
+  - Reserve and practice pools: rebalance keeps 20% of the vault in the reserve for withdrawals and splits the rest into one practice pool per protocol, by the on-chain strategy weights. Anyone can call rebalance, but it can only move money toward the strategy. Only the vault can sign a transfer out.
   - UserPosition: one depositor's shares and any pending withdrawal.
 - The user signs a deposit or a withdrawal from their wallet. The program checks it's not paused, the deposit is at least the minimum and under the cap, and the withdrawal fits the instant limits. Anything larger goes through a 30-minute timelock.
 - Two admin roles: the authority changes settings and is the only one who can unpause. The guardian can only pause.
-Do NOT claim: that deposits earn yield, that funds go to Kamino, MarginFi, Drift or Save yet, or that it's audited. The allocator isn't built; deposits stay in the reserve.
+Do NOT claim: that deposits earn market yield, that funds go to Kamino, MarginFi, Drift or Save yet, or that it's audited. The practice pools pay fixed practice rates from a sponsor pot of test tokens; real protocol integration is next.
 Transition: Each of those controls is a trade-off, so let me be explicit about them.</a:t>
             </a:r>
             <a:endParaRPr lang="en-US" dirty="0"/>
@@ -1803,7 +1803,7 @@
 - The guardian can pause; only the authority can unpause. A fast emergency stop that one key can't abuse. The cost: today there's no escape hatch if the vault stays paused.
 - Shares use 1,000 virtual shares and 1 virtual asset, so the first depositor can't inflate the share price. The cost: tiny rounding losses.
 - Only the program's upgrade authority can create vaults, so nobody can front-run vault creation. The cost: that's a single powerful key.
-- Tests: 10 unit and 5 integration tests run against the compiled program on every change, and an automated job deploys it to a local test network and makes a real deposit and withdrawal.
+- Tests: 14 unit and 10 integration tests run against the compiled program on every change, and an automated job deploys it to a local test network, makes a real deposit, checks the split into practice pools and withdraws.
 Do NOT call it audited or production-ready. Bottom line on the slide: devnet only.
 Transition: Enough slides. Let's look at it working.</a:t>
             </a:r>
@@ -1896,21 +1896,21 @@
               <a:t>TIME: 15 seconds for the slide; the live demo itself takes 3 to 4 minutes if there's time. If time is short, skip Part B and show this slide only.
 SAY: Part A is live. Part B is a devnet prototype. Keep them separate.
 PART A — live comparison app (stablesaver-web.vercel.app)
-1. Open the site. Point out: no wallet or sign-up.
-2. Type an amount, e.g. $1,000, USDC.
-3. Click Play it safe, then Balanced, then Go bigger. The recommendation and the list change.
-4. Open the top option. Show the rate chart (drag across it), then "How risky is it?": the grade and each factor.
-5. Show "What $1,000 could earn" and "You'd keep in a year" after network fees.
-6. Type $100 and pick the Ethereum chip. If the live data still shows it, an option is marked "Fees cost more than you'd earn". If it doesn't, say so and move on.
+1. Open the site (no wallet or sign-up). Click "Find idle money in my wallet" and paste a wallet address: it reads the USDC and USDT on Solana, read-only, and fills the calculator.
+2. Click Play it safe, then Balanced, then Go bigger. The recommendation and the list change.
+3. Open the top option. Show the rate chart (drag across it), "Can I withdraw today?" and "How risky is it?": the grade and each factor.
+4. Point at the "For comparison" row: US Treasury bills, from the US Treasury's own data, with no crypto risk.
+5. Type $100 and pick the Ethereum chip. If the live data still shows it, an option is marked "Fees cost more than you'd earn". If it doesn't, say so and move on.
+6. Click "Share my estimate": the link previews as a card with the estimate. The QR code on the last slide opens the same site.
 PART B — devnet vault
 Before the talk: Vercel has the three devnet variables set and redeployed; Solflare is on devnet with test tokens and a little devnet SOL; do one dry run.
-1. Show the wallet is on devnet (Solflare: Settings, Network, Devnet).
-2. Open Vault. The badge should say Devnet, not Preview.
-3. Connect the wallet.
-4. Deposit some test tokens; approve in the wallet.
-5. Show the position.
-6. Withdraw more than 2,000: 2,000 arrives now, the rest is requested and unlocks in 30 minutes. Don't wait for it live.
-Say out loud: devnet tokens have no value, and the vault doesn't deploy funds into Kamino or the others yet, so nothing earns here.
+1. Show the wallet is on devnet (Solflare: Settings, Network, Devnet), open Vault (the badge says Devnet, not Preview) and connect.
+2. Deposit some test tokens; approve in the wallet. The same transaction splits the deposit into the practice pools.
+3. "Where the vault's money is": 20% kept liquid, the rest in a pool per protocol, read from the chain.
+4. Click "Collect interest &amp; rebalance": anyone can press it, and it can only move money toward the on-chain strategy.
+5. Withdraw more than the reserve holds: the program pulls the difference back from the pools. Above 2,000 the rest waits 30 minutes; don't wait live.
+6. Open the Blink from the Vault page: the same deposit, from a link or QR code.
+Say out loud: devnet tokens have no value; the pools pay fixed practice rates, not market yield.
 Backup if the network fails: use these screenshots and the recorded run if you made one.</a:t>
             </a:r>
             <a:endParaRPr lang="en-US" dirty="0"/>
@@ -2935,7 +2935,7 @@
                   <a:schemeClr val="bg1"/>
                 </a:solidFill>
               </a:rPr>
-              <a:t>DefiLlama-backed pool data</a:t>
+              <a:t>Risk grades and explanations</a:t>
             </a:r>
             <a:endParaRPr lang="en-US" sz="1350" dirty="0"/>
           </a:p>
@@ -2953,7 +2953,7 @@
                   <a:schemeClr val="bg1"/>
                 </a:solidFill>
               </a:rPr>
-              <a:t>Risk grades and explanations</a:t>
+              <a:t>Fee-adjusted earnings estimates</a:t>
             </a:r>
             <a:endParaRPr lang="en-US" sz="1350" dirty="0"/>
           </a:p>
@@ -2971,7 +2971,7 @@
                   <a:schemeClr val="bg1"/>
                 </a:solidFill>
               </a:rPr>
-              <a:t>Fee-adjusted earnings estimates</a:t>
+              <a:t>Withdraw-today check, T-bill comparison</a:t>
             </a:r>
             <a:endParaRPr lang="en-US" sz="1350" dirty="0"/>
           </a:p>
@@ -2989,7 +2989,7 @@
                   <a:schemeClr val="bg1"/>
                 </a:solidFill>
               </a:rPr>
-              <a:t>Optional API endpoints</a:t>
+              <a:t>Idle-money scan and share cards</a:t>
             </a:r>
             <a:endParaRPr lang="en-US" sz="1350" dirty="0"/>
           </a:p>
@@ -3110,7 +3110,7 @@
                   <a:schemeClr val="bg1"/>
                 </a:solidFill>
               </a:rPr>
-              <a:t>Deposits and shares</a:t>
+              <a:t>Deposits, shares, limits, timelock</a:t>
             </a:r>
             <a:endParaRPr lang="en-US" sz="1350" dirty="0"/>
           </a:p>
@@ -3128,7 +3128,25 @@
                   <a:schemeClr val="bg1"/>
                 </a:solidFill>
               </a:rPr>
-              <a:t>Withdrawal limits and timelock</a:t>
+              <a:t>Split into practice pools on-chain</a:t>
+            </a:r>
+            <a:endParaRPr lang="en-US" sz="1350" dirty="0"/>
+          </a:p>
+          <a:p>
+            <a:pPr marL="177800" indent="-177800">
+              <a:spcAft>
+                <a:spcPts val="700"/>
+              </a:spcAft>
+              <a:buSzPct val="100000"/>
+              <a:buChar char="•"/>
+            </a:pPr>
+            <a:r>
+              <a:rPr lang="en-US" sz="1350" dirty="0">
+                <a:solidFill>
+                  <a:schemeClr val="bg1"/>
+                </a:solidFill>
+              </a:rPr>
+              <a:t>Deposit Blink (Solana Action)</a:t>
             </a:r>
             <a:endParaRPr lang="en-US" sz="1350" dirty="0"/>
           </a:p>
@@ -3249,7 +3267,7 @@
                   <a:schemeClr val="bg1"/>
                 </a:solidFill>
               </a:rPr>
-              <a:t>Allocator into lending protocols</a:t>
+              <a:t>CPI into Kamino, MarginFi, Drift and Save</a:t>
             </a:r>
             <a:endParaRPr lang="en-US" sz="1350" dirty="0"/>
           </a:p>
@@ -3267,25 +3285,7 @@
                   <a:schemeClr val="bg1"/>
                 </a:solidFill>
               </a:rPr>
-              <a:t>Real yield through the vault</a:t>
-            </a:r>
-            <a:endParaRPr lang="en-US" sz="1350" dirty="0"/>
-          </a:p>
-          <a:p>
-            <a:pPr marL="177800" indent="-177800">
-              <a:spcAft>
-                <a:spcPts val="700"/>
-              </a:spcAft>
-              <a:buSzPct val="100000"/>
-              <a:buChar char="•"/>
-            </a:pPr>
-            <a:r>
-              <a:rPr lang="en-US" sz="1350" dirty="0">
-                <a:solidFill>
-                  <a:schemeClr val="bg1"/>
-                </a:solidFill>
-              </a:rPr>
-              <a:t>Deployed balances read on-chain, not reported by an admin</a:t>
+              <a:t>Market yield through the vault</a:t>
             </a:r>
             <a:endParaRPr lang="en-US" sz="1350" dirty="0"/>
           </a:p>
@@ -4553,7 +4553,7 @@
                   <a:schemeClr val="bg1"/>
                 </a:solidFill>
               </a:rPr>
-              <a:t>One real Kamino lending strategy</a:t>
+              <a:t>Swap a practice pool for one real Kamino strategy</a:t>
             </a:r>
             <a:endParaRPr lang="en-US" sz="1300" dirty="0"/>
           </a:p>
@@ -4675,7 +4675,7 @@
                   <a:schemeClr val="bg1"/>
                 </a:solidFill>
               </a:rPr>
-              <a:t>Deployed balance read on-chain</a:t>
+              <a:t>Same rebalance and on-chain balances</a:t>
             </a:r>
             <a:endParaRPr lang="en-US" sz="1300" dirty="0"/>
           </a:p>
@@ -4982,7 +4982,7 @@
                   <a:schemeClr val="bg1"/>
                 </a:solidFill>
               </a:rPr>
-              <a:t>Blinks, alerts, read-only portfolio, more tokens</a:t>
+              <a:t>Alerts, read-only portfolio, more tokens</a:t>
             </a:r>
             <a:endParaRPr lang="en-US" sz="1300" dirty="0"/>
           </a:p>
@@ -11278,7 +11278,7 @@
                   <a:schemeClr val="accent3"/>
                 </a:solidFill>
               </a:rPr>
-              <a:t>No yield yet</a:t>
+              <a:t>Practice pools</a:t>
             </a:r>
             <a:endParaRPr lang="en-US" sz="1300" dirty="0"/>
           </a:p>
@@ -11401,7 +11401,7 @@
                   <a:schemeClr val="bg2"/>
                 </a:solidFill>
               </a:rPr>
-              <a:t>Anchor · Solana devnet · 13 instructions</a:t>
+              <a:t>Anchor · Solana devnet · 16 instructions</a:t>
             </a:r>
             <a:endParaRPr lang="en-US" sz="1100" dirty="0"/>
           </a:p>
@@ -12118,7 +12118,7 @@
                   <a:schemeClr val="accent2"/>
                 </a:solidFill>
               </a:rPr>
-              <a:t>Reserve PDA</a:t>
+              <a:t>Reserve + practice pools</a:t>
             </a:r>
             <a:endParaRPr lang="en-US" sz="1400" dirty="0"/>
           </a:p>
@@ -12157,7 +12157,7 @@
                 <a:ea typeface="Courier New" pitchFamily="34" charset="-122"/>
                 <a:cs typeface="Courier New" pitchFamily="34" charset="-120"/>
               </a:rPr>
-              <a:t>["reserve", vault]</a:t>
+              <a:t>["reserve"] · ["pool", protocol]</a:t>
             </a:r>
             <a:endParaRPr lang="en-US" sz="1050" dirty="0"/>
           </a:p>
@@ -12193,7 +12193,7 @@
                   <a:schemeClr val="bg2"/>
                 </a:solidFill>
               </a:rPr>
-              <a:t>The deposited tokens; only the vault signs transfers out</a:t>
+              <a:t>20% kept liquid; the rest split by strategy weight. Only the vault signs transfers out</a:t>
             </a:r>
             <a:endParaRPr lang="en-US" sz="1150" dirty="0"/>
           </a:p>
@@ -14179,7 +14179,7 @@
                   <a:schemeClr val="bg1"/>
                 </a:solidFill>
               </a:rPr>
-              <a:t>Open the site</a:t>
+              <a:t>Find idle money in a wallet</a:t>
             </a:r>
             <a:endParaRPr lang="en-US" sz="1300" dirty="0"/>
           </a:p>
@@ -14257,7 +14257,7 @@
                   <a:schemeClr val="bg1"/>
                 </a:solidFill>
               </a:rPr>
-              <a:t>Enter an amount</a:t>
+              <a:t>Switch Safe / Balanced / Bigger</a:t>
             </a:r>
             <a:endParaRPr lang="en-US" sz="1300" dirty="0"/>
           </a:p>
@@ -14335,7 +14335,7 @@
                   <a:schemeClr val="bg1"/>
                 </a:solidFill>
               </a:rPr>
-              <a:t>Switch Safe / Balanced / Bigger</a:t>
+              <a:t>Open an option: grade, withdraw</a:t>
             </a:r>
             <a:endParaRPr lang="en-US" sz="1300" dirty="0"/>
           </a:p>
@@ -14413,7 +14413,7 @@
                   <a:schemeClr val="bg1"/>
                 </a:solidFill>
               </a:rPr>
-              <a:t>Open an option: the grade</a:t>
+              <a:t>Compare with US T-bills</a:t>
             </a:r>
             <a:endParaRPr lang="en-US" sz="1300" dirty="0"/>
           </a:p>
@@ -14491,7 +14491,7 @@
                   <a:schemeClr val="bg1"/>
                 </a:solidFill>
               </a:rPr>
-              <a:t>Show earnings after fees</a:t>
+              <a:t>$100 + Ethereum: fees win</a:t>
             </a:r>
             <a:endParaRPr lang="en-US" sz="1300" dirty="0"/>
           </a:p>
@@ -14569,7 +14569,7 @@
                   <a:schemeClr val="bg1"/>
                 </a:solidFill>
               </a:rPr>
-              <a:t>$100 + Ethereum: fees win</a:t>
+              <a:t>Share my estimate</a:t>
             </a:r>
             <a:endParaRPr lang="en-US" sz="1300" dirty="0"/>
           </a:p>
@@ -14841,7 +14841,7 @@
                   <a:schemeClr val="bg1"/>
                 </a:solidFill>
               </a:rPr>
-              <a:t>Switch wallet to devnet</a:t>
+              <a:t>Connect a devnet wallet</a:t>
             </a:r>
             <a:endParaRPr lang="en-US" sz="1300" dirty="0"/>
           </a:p>
@@ -14919,7 +14919,7 @@
                   <a:schemeClr val="bg1"/>
                 </a:solidFill>
               </a:rPr>
-              <a:t>Open Vault</a:t>
+              <a:t>Deposit: split into pools</a:t>
             </a:r>
             <a:endParaRPr lang="en-US" sz="1300" dirty="0"/>
           </a:p>
@@ -14997,7 +14997,7 @@
                   <a:schemeClr val="bg1"/>
                 </a:solidFill>
               </a:rPr>
-              <a:t>Connect the wallet</a:t>
+              <a:t>Where the money is</a:t>
             </a:r>
             <a:endParaRPr lang="en-US" sz="1300" dirty="0"/>
           </a:p>
@@ -15075,7 +15075,7 @@
                   <a:schemeClr val="bg1"/>
                 </a:solidFill>
               </a:rPr>
-              <a:t>Deposit test tokens</a:t>
+              <a:t>Collect interest, rebalance</a:t>
             </a:r>
             <a:endParaRPr lang="en-US" sz="1300" dirty="0"/>
           </a:p>
@@ -15153,7 +15153,7 @@
                   <a:schemeClr val="bg1"/>
                 </a:solidFill>
               </a:rPr>
-              <a:t>Show the position</a:t>
+              <a:t>Withdraw: pools top up</a:t>
             </a:r>
             <a:endParaRPr lang="en-US" sz="1300" dirty="0"/>
           </a:p>
@@ -15231,7 +15231,7 @@
                   <a:schemeClr val="bg1"/>
                 </a:solidFill>
               </a:rPr>
-              <a:t>Withdraw: 2,000 now, rest waits</a:t>
+              <a:t>Deposit from a Blink</a:t>
             </a:r>
             <a:endParaRPr lang="en-US" sz="1300" dirty="0"/>
           </a:p>
@@ -15329,7 +15329,7 @@
                   <a:schemeClr val="bg2"/>
                 </a:solidFill>
               </a:rPr>
-              <a:t>The vault doesn't move funds into yield protocols yet. Thumbnails: local build (demo data; vault in simulated preview).</a:t>
+              <a:t>Practice pools pay fixed practice rates, not market yield. Thumbnails: local build (demo data; vault in simulated preview).</a:t>
             </a:r>
             <a:endParaRPr lang="en-US" sz="1150" dirty="0"/>
           </a:p>

</xml_diff>

<commit_message>
Add an on-site Blink and show vault action errors
The vault's Blink card now opens /vault/blink, which draws the deposit
Action the way a Blink client does (GET the metadata, POST the wallet,
sign the returned transaction), so it works without dial.to; the card
still copies the dial.to link for sharing. Collect interest, execute and
cancel used to fail silently; their errors now show on the page, and a
wallet on the wrong network gets a plain 'switch to Devnet' message. The
devnet banner says the wallet must be on Devnet too.
</commit_message>
<xml_diff>
--- a/presentation/StableSave-Demo-Day.pptx
+++ b/presentation/StableSave-Demo-Day.pptx
@@ -124,14 +124,14 @@
   <p:extLst>
     <p:ext uri="{521415D9-36F7-43E2-AB2F-B90AF26B5E84}">
       <p14:sectionLst xmlns:p14="http://schemas.microsoft.com/office/powerpoint/2010/main">
-        <p14:section name="Opening" id="{d5eb47c8-56bd-f52b-5d64-4178689f83d6}">
+        <p14:section name="Opening" id="{f09b2c17-e1e1-bf9b-efbc-5180a0b5ead3}">
           <p14:sldIdLst>
             <p14:sldId id="256"/>
             <p14:sldId id="257"/>
             <p14:sldId id="258"/>
           </p14:sldIdLst>
         </p14:section>
-        <p14:section name="Comparison app" id="{560738c1-5a38-7840-28a2-aa986b25dbb4}">
+        <p14:section name="Comparison app" id="{fc67515a-c702-9072-a02e-94c27f9b5399}">
           <p14:sldIdLst>
             <p14:sldId id="259"/>
             <p14:sldId id="260"/>
@@ -141,7 +141,7 @@
             <p14:sldId id="264"/>
           </p14:sldIdLst>
         </p14:section>
-        <p14:section name="Solana vault" id="{e03c5e02-10a5-96de-08e9-c238ef0b2df6}">
+        <p14:section name="Solana vault" id="{db9a0b08-7975-23a8-af16-fd84cf927690}">
           <p14:sldIdLst>
             <p14:sldId id="265"/>
             <p14:sldId id="266"/>
@@ -149,7 +149,7 @@
             <p14:sldId id="268"/>
           </p14:sldIdLst>
         </p14:section>
-        <p14:section name="Demo and roadmap" id="{ec7794b8-d494-b5f7-f039-8e0dcde5e2c3}">
+        <p14:section name="Demo and roadmap" id="{d1943042-3008-9237-c3fe-52985f95b120}">
           <p14:sldIdLst>
             <p14:sldId id="269"/>
             <p14:sldId id="270"/>
@@ -157,7 +157,7 @@
             <p14:sldId id="272"/>
           </p14:sldIdLst>
         </p14:section>
-        <p14:section name="Close" id="{b7a6f1c7-35c6-e0c2-a56e-7ff9913f4159}">
+        <p14:section name="Close" id="{1b6b3e38-eea0-3378-7bd1-d58c4438b644}">
           <p14:sldIdLst>
             <p14:sldId id="273"/>
           </p14:sldIdLst>
@@ -2010,12 +2010,12 @@
 6. Click "Share my estimate": the link previews as a card with the estimate. The QR code on the last slide opens the same site.
 PART B — devnet vault
 Before the talk: Vercel has the three devnet variables set and redeployed; Solflare is on devnet with test tokens and a little devnet SOL; do one dry run.
-1. Show the wallet is on devnet (Solflare: Settings, Network, Devnet), open Vault (the badge says Devnet, not Preview) and connect.
+1. Show the wallet is on devnet (Solflare: Settings, Network, Devnet; if it's on mainnet it warns and simulates there), open Vault (the badge says Devnet, not Preview) and connect.
 2. Deposit some test tokens; approve in the wallet. The same transaction splits the deposit into the practice pools.
 3. "Where the vault's money is": 20% kept liquid, the rest in a pool per protocol, read from the chain.
 4. Click "Collect interest &amp; rebalance": anyone can press it, and it can only move money toward the on-chain strategy.
 5. Withdraw more than the reserve holds: the program pulls the difference back from the pools. Above 2,000 the rest waits 30 minutes; don't wait live.
-6. Open the Blink from the Vault page: the same deposit, from a link or QR code.
+6. On the Vault page, press "Try it" on the Blink card: the same deposit, drawn from the Solana Action that wallets and dial.to read. "Copy link" gives the dial.to link to share.
 Say out loud: devnet tokens have no value; the pools pay fixed practice rates, not market yield.
 Backup if the network fails: use these screenshots and the recorded run if you made one.</a:t>
             </a:r>
@@ -6368,7 +6368,7 @@
       </p:sp>
       <p:pic>
         <p:nvPicPr>
-          <p:cNvPr id="8" name="shot-blink" descr="Deposit from a link: a Solana Blink anyone with test USDC can use from a post or a QR code. Copy link, Open Blink">    </p:cNvPr>
+          <p:cNvPr id="8" name="shot-blink" descr="Deposit from a link: a Solana Blink anyone with test USDC can use from a post or a QR code. Copy link, Try it">    </p:cNvPr>
           <p:cNvPicPr>
             <a:picLocks noChangeAspect="1"/>
           </p:cNvPicPr>

</xml_diff>